<commit_message>
Rebuild every lesson deck with the corrected multiple-choice option order
53 units, 314 decks, all passing verify_decks.py. The printed answer key
moves with the options, so a deck and the page now show the same order and
a teacher can say 'the answer is C' in either.

Co-Authored-By: Claude Opus 5 <noreply@anthropic.com>
Claude-Session: https://claude.ai/code/session_0193vf6KbwYNomS9SAazprSB
</commit_message>
<xml_diff>
--- a/decks/combined-bonding/combined-bonding_ch1_states-of-matter.pptx
+++ b/decks/combined-bonding/combined-bonding_ch1_states-of-matter.pptx
@@ -126,29 +126,29 @@
   <p:extLst>
     <p:ext uri="{521415D9-36F7-43E2-AB2F-B90AF26B5E84}">
       <p14:sectionLst xmlns:p14="http://schemas.microsoft.com/office/powerpoint/2010/main">
-        <p14:section name="Opening" id="{2befc6cd-df1d-1abd-bfa1-15df87858e77}">
+        <p14:section name="Opening" id="{e6c25644-cfb9-2f59-eb89-307b6500ade6}">
           <p14:sldIdLst>
             <p14:sldId id="256"/>
           </p14:sldIdLst>
         </p14:section>
-        <p14:section name="Gate" id="{a8865a2a-d29d-47e4-d1c1-4b596d24f113}">
+        <p14:section name="Gate" id="{68a016f8-63f3-a82a-56dd-1486c9847a51}">
           <p14:sldIdLst>
             <p14:sldId id="257"/>
             <p14:sldId id="258"/>
           </p14:sldIdLst>
         </p14:section>
-        <p14:section name="Pre-teach" id="{befb3444-fc42-00bc-324f-61fb126c9500}">
+        <p14:section name="Pre-teach" id="{4df03ead-be69-13fb-e584-5b37963c8d6f}">
           <p14:sldIdLst>
             <p14:sldId id="259"/>
           </p14:sldIdLst>
         </p14:section>
-        <p14:section name="Read-along" id="{93762a44-29f1-f27b-92dd-4bdf9f04556d}">
+        <p14:section name="Read-along" id="{0522bed0-07ee-8af9-a410-8ba072e2a3ff}">
           <p14:sldIdLst>
             <p14:sldId id="260"/>
             <p14:sldId id="261"/>
           </p14:sldIdLst>
         </p14:section>
-        <p14:section name="Teach" id="{eb2b2be2-8fca-a781-1878-60a078d85cc3}">
+        <p14:section name="Teach" id="{d99c91a2-463e-4807-7fa2-461eea22ed1d}">
           <p14:sldIdLst>
             <p14:sldId id="262"/>
             <p14:sldId id="263"/>
@@ -158,7 +158,7 @@
             <p14:sldId id="267"/>
           </p14:sldIdLst>
         </p14:section>
-        <p14:section name="Routes" id="{143588c8-2ad6-6e5a-57cc-7179f1af5708}">
+        <p14:section name="Routes" id="{3d988b8d-fc96-0b5f-f062-a4c422ef8cda}">
           <p14:sldIdLst>
             <p14:sldId id="268"/>
             <p14:sldId id="269"/>
@@ -166,12 +166,12 @@
             <p14:sldId id="271"/>
           </p14:sldIdLst>
         </p14:section>
-        <p14:section name="Close" id="{06dc6827-ddb1-55fc-a4e2-9a1aec3b03f7}">
+        <p14:section name="Close" id="{b2356982-56ec-898b-472a-bdfbbf4a212d}">
           <p14:sldIdLst>
             <p14:sldId id="272"/>
           </p14:sldIdLst>
         </p14:section>
-        <p14:section name="Answers" id="{4e372e9b-87b8-ce33-8dc7-3fc7d954b2bc}">
+        <p14:section name="Answers" id="{903237b2-1526-1e40-b829-5e5781f3b7f9}">
           <p14:sldIdLst>
             <p14:sldId id="273"/>
             <p14:sldId id="274"/>
@@ -1420,7 +1420,7 @@
             <a:r>
               <a:rPr lang="en-US" dirty="0"/>
               <a:t>Answers — task 1: Solid, liquid or gas?. Reveal the answer; pupils mark their own work in a different colour, then read the "why" together. Same destination for every lane, so one answer serves the whole class.
-Answer: A   liquid
+Answer: C   liquid
 Why: At 25 °C the substance is above its melting point and below its boiling point, so it is a liquid.
 Ask a Support pupil to explain one step, and a Stretch pupil to share their extension.</a:t>
             </a:r>
@@ -6448,63 +6448,63 @@
                 <a:ea typeface="Calibri" pitchFamily="34" charset="-122"/>
                 <a:cs typeface="Calibri" pitchFamily="34" charset="-120"/>
               </a:rPr>
+              <a:t>solid      </a:t>
+            </a:r>
+            <a:pPr algn="ctr" indent="0" marL="0">
+              <a:buNone/>
+            </a:pPr>
+            <a:r>
+              <a:rPr lang="en-US" sz="2400" b="1" dirty="0">
+                <a:solidFill>
+                  <a:srgbClr val="B8862B"/>
+                </a:solidFill>
+                <a:latin typeface="Calibri" pitchFamily="34" charset="0"/>
+                <a:ea typeface="Calibri" pitchFamily="34" charset="-122"/>
+                <a:cs typeface="Calibri" pitchFamily="34" charset="-120"/>
+              </a:rPr>
+              <a:t>B  </a:t>
+            </a:r>
+            <a:pPr algn="ctr" indent="0" marL="0">
+              <a:buNone/>
+            </a:pPr>
+            <a:r>
+              <a:rPr lang="en-US" sz="2400" dirty="0">
+                <a:solidFill>
+                  <a:srgbClr val="1E2229"/>
+                </a:solidFill>
+                <a:latin typeface="Calibri" pitchFamily="34" charset="0"/>
+                <a:ea typeface="Calibri" pitchFamily="34" charset="-122"/>
+                <a:cs typeface="Calibri" pitchFamily="34" charset="-120"/>
+              </a:rPr>
+              <a:t>gas      </a:t>
+            </a:r>
+            <a:pPr algn="ctr" indent="0" marL="0">
+              <a:buNone/>
+            </a:pPr>
+            <a:r>
+              <a:rPr lang="en-US" sz="2400" b="1" dirty="0">
+                <a:solidFill>
+                  <a:srgbClr val="B8862B"/>
+                </a:solidFill>
+                <a:latin typeface="Calibri" pitchFamily="34" charset="0"/>
+                <a:ea typeface="Calibri" pitchFamily="34" charset="-122"/>
+                <a:cs typeface="Calibri" pitchFamily="34" charset="-120"/>
+              </a:rPr>
+              <a:t>C  </a:t>
+            </a:r>
+            <a:pPr algn="ctr" indent="0" marL="0">
+              <a:buNone/>
+            </a:pPr>
+            <a:r>
+              <a:rPr lang="en-US" sz="2400" dirty="0">
+                <a:solidFill>
+                  <a:srgbClr val="1E2229"/>
+                </a:solidFill>
+                <a:latin typeface="Calibri" pitchFamily="34" charset="0"/>
+                <a:ea typeface="Calibri" pitchFamily="34" charset="-122"/>
+                <a:cs typeface="Calibri" pitchFamily="34" charset="-120"/>
+              </a:rPr>
               <a:t>liquid      </a:t>
-            </a:r>
-            <a:pPr algn="ctr" indent="0" marL="0">
-              <a:buNone/>
-            </a:pPr>
-            <a:r>
-              <a:rPr lang="en-US" sz="2400" b="1" dirty="0">
-                <a:solidFill>
-                  <a:srgbClr val="B8862B"/>
-                </a:solidFill>
-                <a:latin typeface="Calibri" pitchFamily="34" charset="0"/>
-                <a:ea typeface="Calibri" pitchFamily="34" charset="-122"/>
-                <a:cs typeface="Calibri" pitchFamily="34" charset="-120"/>
-              </a:rPr>
-              <a:t>B  </a:t>
-            </a:r>
-            <a:pPr algn="ctr" indent="0" marL="0">
-              <a:buNone/>
-            </a:pPr>
-            <a:r>
-              <a:rPr lang="en-US" sz="2400" dirty="0">
-                <a:solidFill>
-                  <a:srgbClr val="1E2229"/>
-                </a:solidFill>
-                <a:latin typeface="Calibri" pitchFamily="34" charset="0"/>
-                <a:ea typeface="Calibri" pitchFamily="34" charset="-122"/>
-                <a:cs typeface="Calibri" pitchFamily="34" charset="-120"/>
-              </a:rPr>
-              <a:t>solid      </a:t>
-            </a:r>
-            <a:pPr algn="ctr" indent="0" marL="0">
-              <a:buNone/>
-            </a:pPr>
-            <a:r>
-              <a:rPr lang="en-US" sz="2400" b="1" dirty="0">
-                <a:solidFill>
-                  <a:srgbClr val="B8862B"/>
-                </a:solidFill>
-                <a:latin typeface="Calibri" pitchFamily="34" charset="0"/>
-                <a:ea typeface="Calibri" pitchFamily="34" charset="-122"/>
-                <a:cs typeface="Calibri" pitchFamily="34" charset="-120"/>
-              </a:rPr>
-              <a:t>C  </a:t>
-            </a:r>
-            <a:pPr algn="ctr" indent="0" marL="0">
-              <a:buNone/>
-            </a:pPr>
-            <a:r>
-              <a:rPr lang="en-US" sz="2400" dirty="0">
-                <a:solidFill>
-                  <a:srgbClr val="1E2229"/>
-                </a:solidFill>
-                <a:latin typeface="Calibri" pitchFamily="34" charset="0"/>
-                <a:ea typeface="Calibri" pitchFamily="34" charset="-122"/>
-                <a:cs typeface="Calibri" pitchFamily="34" charset="-120"/>
-              </a:rPr>
-              <a:t>gas      </a:t>
             </a:r>
             <a:pPr algn="ctr" indent="0" marL="0">
               <a:buNone/>
@@ -9781,7 +9781,7 @@
                 <a:ea typeface="Cambria" pitchFamily="34" charset="-122"/>
                 <a:cs typeface="Cambria" pitchFamily="34" charset="-120"/>
               </a:rPr>
-              <a:t>A   liquid</a:t>
+              <a:t>C   liquid</a:t>
             </a:r>
             <a:endParaRPr lang="en-US" sz="1800" dirty="0"/>
           </a:p>
@@ -10922,7 +10922,7 @@
                 <a:ea typeface="Calibri" pitchFamily="34" charset="-122"/>
                 <a:cs typeface="Calibri" pitchFamily="34" charset="-120"/>
               </a:rPr>
-              <a:t>Close together, in a random arrangement, moving around one another</a:t>
+              <a:t>Far apart, in a regular pattern, vibrating on the spot</a:t>
             </a:r>
             <a:endParaRPr lang="en-US" sz="1800" dirty="0"/>
           </a:p>
@@ -10996,7 +10996,7 @@
                 <a:ea typeface="Calibri" pitchFamily="34" charset="-122"/>
                 <a:cs typeface="Calibri" pitchFamily="34" charset="-120"/>
               </a:rPr>
-              <a:t>Far apart, in a regular pattern, vibrating on the spot</a:t>
+              <a:t>Close together, in a random arrangement, moving around one another</a:t>
             </a:r>
             <a:endParaRPr lang="en-US" sz="1800" dirty="0"/>
           </a:p>

</xml_diff>